<commit_message>
Folletos 2026-05 - generacion automatica
</commit_message>
<xml_diff>
--- a/folletos/2026-04/pptx/FIP_VANTRUST_LIQUIDEZ_ACTIVA.pptx
+++ b/folletos/2026-04/pptx/FIP_VANTRUST_LIQUIDEZ_ACTIVA.pptx
@@ -6373,7 +6373,7 @@
                 <a:ea typeface="Calibri" pitchFamily="34" charset="-122"/>
                 <a:cs typeface="Calibri" pitchFamily="34" charset="-120"/>
               </a:rPr>
-              <a:t>prueba 6 CLP</a:t>
+              <a:t>prueba CLP</a:t>
             </a:r>
             <a:endParaRPr lang="en-US" sz="800" dirty="0"/>
           </a:p>
@@ -33352,13 +33352,91 @@
       </p:sp>
       <p:sp>
         <p:nvSpPr>
-          <p:cNvPr id="8" name="Shape 6"/>
+          <p:cNvPr id="8" name="Text 6"/>
           <p:cNvSpPr/>
           <p:nvPr/>
         </p:nvSpPr>
         <p:spPr>
           <a:xfrm>
-            <a:off x="118872" y="1810512"/>
+            <a:off x="118872" y="1719072"/>
+            <a:ext cx="1188720" cy="173736"/>
+          </a:xfrm>
+          <a:prstGeom prst="rect">
+            <a:avLst/>
+          </a:prstGeom>
+          <a:noFill/>
+          <a:ln/>
+        </p:spPr>
+        <p:txBody>
+          <a:bodyPr wrap="square" lIns="0" tIns="0" rIns="0" bIns="0" rtlCol="0" anchor="ctr"/>
+          <a:lstStyle/>
+          <a:p>
+            <a:pPr indent="0" marL="0">
+              <a:buNone/>
+            </a:pPr>
+            <a:r>
+              <a:rPr lang="en-US" sz="750" dirty="0">
+                <a:solidFill>
+                  <a:srgbClr val="000000"/>
+                </a:solidFill>
+                <a:latin typeface="Calibri" pitchFamily="34" charset="0"/>
+                <a:ea typeface="Calibri" pitchFamily="34" charset="-122"/>
+                <a:cs typeface="Calibri" pitchFamily="34" charset="-120"/>
+              </a:rPr>
+              <a:t>CLP</a:t>
+            </a:r>
+            <a:endParaRPr lang="en-US" sz="750" dirty="0"/>
+          </a:p>
+        </p:txBody>
+      </p:sp>
+      <p:sp>
+        <p:nvSpPr>
+          <p:cNvPr id="9" name="Text 7"/>
+          <p:cNvSpPr/>
+          <p:nvPr/>
+        </p:nvSpPr>
+        <p:spPr>
+          <a:xfrm>
+            <a:off x="1307592" y="1719072"/>
+            <a:ext cx="1024128" cy="173736"/>
+          </a:xfrm>
+          <a:prstGeom prst="rect">
+            <a:avLst/>
+          </a:prstGeom>
+          <a:noFill/>
+          <a:ln/>
+        </p:spPr>
+        <p:txBody>
+          <a:bodyPr wrap="square" lIns="0" tIns="0" rIns="0" bIns="0" rtlCol="0" anchor="ctr"/>
+          <a:lstStyle/>
+          <a:p>
+            <a:pPr algn="r" indent="0" marL="0">
+              <a:buNone/>
+            </a:pPr>
+            <a:r>
+              <a:rPr lang="en-US" sz="750" b="1" dirty="0">
+                <a:solidFill>
+                  <a:srgbClr val="000000"/>
+                </a:solidFill>
+                <a:latin typeface="Calibri" pitchFamily="34" charset="0"/>
+                <a:ea typeface="Calibri" pitchFamily="34" charset="-122"/>
+                <a:cs typeface="Calibri" pitchFamily="34" charset="-120"/>
+              </a:rPr>
+              <a:t>100,00%</a:t>
+            </a:r>
+            <a:endParaRPr lang="en-US" sz="750" dirty="0"/>
+          </a:p>
+        </p:txBody>
+      </p:sp>
+      <p:sp>
+        <p:nvSpPr>
+          <p:cNvPr id="10" name="Shape 8"/>
+          <p:cNvSpPr/>
+          <p:nvPr/>
+        </p:nvSpPr>
+        <p:spPr>
+          <a:xfrm>
+            <a:off x="118872" y="2002536"/>
             <a:ext cx="2212848" cy="0"/>
           </a:xfrm>
           <a:prstGeom prst="line">
@@ -33375,13 +33453,13 @@
       </p:sp>
       <p:sp>
         <p:nvSpPr>
-          <p:cNvPr id="9" name="Text 7"/>
+          <p:cNvPr id="11" name="Text 9"/>
           <p:cNvSpPr/>
           <p:nvPr/>
         </p:nvSpPr>
         <p:spPr>
           <a:xfrm>
-            <a:off x="118872" y="1901952"/>
+            <a:off x="118872" y="2093976"/>
             <a:ext cx="2212848" cy="164592"/>
           </a:xfrm>
           <a:prstGeom prst="rect">
@@ -33414,13 +33492,13 @@
       </p:sp>
       <p:sp>
         <p:nvSpPr>
-          <p:cNvPr id="10" name="Shape 8"/>
+          <p:cNvPr id="12" name="Shape 10"/>
           <p:cNvSpPr/>
           <p:nvPr/>
         </p:nvSpPr>
         <p:spPr>
           <a:xfrm>
-            <a:off x="118872" y="2084832"/>
+            <a:off x="118872" y="2276856"/>
             <a:ext cx="2212848" cy="0"/>
           </a:xfrm>
           <a:prstGeom prst="line">
@@ -33437,13 +33515,13 @@
       </p:sp>
       <p:sp>
         <p:nvSpPr>
-          <p:cNvPr id="11" name="Text 9"/>
+          <p:cNvPr id="13" name="Text 11"/>
           <p:cNvSpPr/>
           <p:nvPr/>
         </p:nvSpPr>
         <p:spPr>
           <a:xfrm>
-            <a:off x="118872" y="2157984"/>
+            <a:off x="118872" y="2350008"/>
             <a:ext cx="1371600" cy="164592"/>
           </a:xfrm>
           <a:prstGeom prst="rect">
@@ -33476,13 +33554,13 @@
       </p:sp>
       <p:sp>
         <p:nvSpPr>
-          <p:cNvPr id="12" name="Text 10"/>
+          <p:cNvPr id="14" name="Text 12"/>
           <p:cNvSpPr/>
           <p:nvPr/>
         </p:nvSpPr>
         <p:spPr>
           <a:xfrm>
-            <a:off x="1490472" y="2157984"/>
+            <a:off x="1490472" y="2350008"/>
             <a:ext cx="841248" cy="164592"/>
           </a:xfrm>
           <a:prstGeom prst="rect">
@@ -33515,13 +33593,13 @@
       </p:sp>
       <p:sp>
         <p:nvSpPr>
-          <p:cNvPr id="13" name="Shape 11"/>
+          <p:cNvPr id="15" name="Shape 13"/>
           <p:cNvSpPr/>
           <p:nvPr/>
         </p:nvSpPr>
         <p:spPr>
           <a:xfrm>
-            <a:off x="118872" y="2423160"/>
+            <a:off x="118872" y="2615184"/>
             <a:ext cx="2212848" cy="0"/>
           </a:xfrm>
           <a:prstGeom prst="line">
@@ -33538,13 +33616,13 @@
       </p:sp>
       <p:sp>
         <p:nvSpPr>
-          <p:cNvPr id="14" name="Text 12"/>
+          <p:cNvPr id="16" name="Text 14"/>
           <p:cNvSpPr/>
           <p:nvPr/>
         </p:nvSpPr>
         <p:spPr>
           <a:xfrm>
-            <a:off x="118872" y="2514600"/>
+            <a:off x="118872" y="2706624"/>
             <a:ext cx="2212848" cy="164592"/>
           </a:xfrm>
           <a:prstGeom prst="rect">
@@ -33577,13 +33655,13 @@
       </p:sp>
       <p:sp>
         <p:nvSpPr>
-          <p:cNvPr id="15" name="Shape 13"/>
+          <p:cNvPr id="17" name="Shape 15"/>
           <p:cNvSpPr/>
           <p:nvPr/>
         </p:nvSpPr>
         <p:spPr>
           <a:xfrm>
-            <a:off x="118872" y="2697480"/>
+            <a:off x="118872" y="2889504"/>
             <a:ext cx="2212848" cy="0"/>
           </a:xfrm>
           <a:prstGeom prst="line">
@@ -33600,13 +33678,13 @@
       </p:sp>
       <p:sp>
         <p:nvSpPr>
-          <p:cNvPr id="16" name="Text 14"/>
+          <p:cNvPr id="18" name="Text 16"/>
           <p:cNvSpPr/>
           <p:nvPr/>
         </p:nvSpPr>
         <p:spPr>
           <a:xfrm>
-            <a:off x="118872" y="2770632"/>
+            <a:off x="118872" y="2962656"/>
             <a:ext cx="1371600" cy="182880"/>
           </a:xfrm>
           <a:prstGeom prst="rect">
@@ -33639,13 +33717,13 @@
       </p:sp>
       <p:sp>
         <p:nvSpPr>
-          <p:cNvPr id="17" name="Text 15"/>
+          <p:cNvPr id="19" name="Text 17"/>
           <p:cNvSpPr/>
           <p:nvPr/>
         </p:nvSpPr>
         <p:spPr>
           <a:xfrm>
-            <a:off x="1490472" y="2770632"/>
+            <a:off x="1490472" y="2962656"/>
             <a:ext cx="841248" cy="182880"/>
           </a:xfrm>
           <a:prstGeom prst="rect">
@@ -33678,13 +33756,13 @@
       </p:sp>
       <p:sp>
         <p:nvSpPr>
-          <p:cNvPr id="18" name="Text 16"/>
+          <p:cNvPr id="20" name="Text 18"/>
           <p:cNvSpPr/>
           <p:nvPr/>
         </p:nvSpPr>
         <p:spPr>
           <a:xfrm>
-            <a:off x="118872" y="2971800"/>
+            <a:off x="118872" y="3163824"/>
             <a:ext cx="1371600" cy="182880"/>
           </a:xfrm>
           <a:prstGeom prst="rect">
@@ -33717,13 +33795,13 @@
       </p:sp>
       <p:sp>
         <p:nvSpPr>
-          <p:cNvPr id="19" name="Text 17"/>
+          <p:cNvPr id="21" name="Text 19"/>
           <p:cNvSpPr/>
           <p:nvPr/>
         </p:nvSpPr>
         <p:spPr>
           <a:xfrm>
-            <a:off x="1490472" y="2971800"/>
+            <a:off x="1490472" y="3163824"/>
             <a:ext cx="841248" cy="182880"/>
           </a:xfrm>
           <a:prstGeom prst="rect">
@@ -33756,13 +33834,13 @@
       </p:sp>
       <p:sp>
         <p:nvSpPr>
-          <p:cNvPr id="20" name="Text 18"/>
+          <p:cNvPr id="22" name="Text 20"/>
           <p:cNvSpPr/>
           <p:nvPr/>
         </p:nvSpPr>
         <p:spPr>
           <a:xfrm>
-            <a:off x="118872" y="3172968"/>
+            <a:off x="118872" y="3364992"/>
             <a:ext cx="1371600" cy="182880"/>
           </a:xfrm>
           <a:prstGeom prst="rect">
@@ -33795,13 +33873,13 @@
       </p:sp>
       <p:sp>
         <p:nvSpPr>
-          <p:cNvPr id="21" name="Text 19"/>
+          <p:cNvPr id="23" name="Text 21"/>
           <p:cNvSpPr/>
           <p:nvPr/>
         </p:nvSpPr>
         <p:spPr>
           <a:xfrm>
-            <a:off x="1490472" y="3172968"/>
+            <a:off x="1490472" y="3364992"/>
             <a:ext cx="841248" cy="182880"/>
           </a:xfrm>
           <a:prstGeom prst="rect">
@@ -33834,13 +33912,13 @@
       </p:sp>
       <p:sp>
         <p:nvSpPr>
-          <p:cNvPr id="22" name="Text 20"/>
+          <p:cNvPr id="24" name="Text 22"/>
           <p:cNvSpPr/>
           <p:nvPr/>
         </p:nvSpPr>
         <p:spPr>
           <a:xfrm>
-            <a:off x="118872" y="3374136"/>
+            <a:off x="118872" y="3566160"/>
             <a:ext cx="1371600" cy="182880"/>
           </a:xfrm>
           <a:prstGeom prst="rect">
@@ -33873,13 +33951,13 @@
       </p:sp>
       <p:sp>
         <p:nvSpPr>
-          <p:cNvPr id="23" name="Text 21"/>
+          <p:cNvPr id="25" name="Text 23"/>
           <p:cNvSpPr/>
           <p:nvPr/>
         </p:nvSpPr>
         <p:spPr>
           <a:xfrm>
-            <a:off x="1490472" y="3374136"/>
+            <a:off x="1490472" y="3566160"/>
             <a:ext cx="841248" cy="182880"/>
           </a:xfrm>
           <a:prstGeom prst="rect">
@@ -33912,7 +33990,7 @@
       </p:sp>
       <p:sp>
         <p:nvSpPr>
-          <p:cNvPr id="24" name="Text 22"/>
+          <p:cNvPr id="26" name="Text 24"/>
           <p:cNvSpPr/>
           <p:nvPr/>
         </p:nvSpPr>
@@ -33951,7 +34029,7 @@
       </p:sp>
       <p:sp>
         <p:nvSpPr>
-          <p:cNvPr id="25" name="Shape 23"/>
+          <p:cNvPr id="27" name="Shape 25"/>
           <p:cNvSpPr/>
           <p:nvPr/>
         </p:nvSpPr>
@@ -33974,7 +34052,7 @@
       </p:sp>
       <p:sp>
         <p:nvSpPr>
-          <p:cNvPr id="26" name="Text 24"/>
+          <p:cNvPr id="28" name="Text 26"/>
           <p:cNvSpPr/>
           <p:nvPr/>
         </p:nvSpPr>
@@ -34030,7 +34108,7 @@
       </p:sp>
       <p:sp>
         <p:nvSpPr>
-          <p:cNvPr id="27" name="Text 25"/>
+          <p:cNvPr id="29" name="Text 27"/>
           <p:cNvSpPr/>
           <p:nvPr/>
         </p:nvSpPr>
@@ -34086,7 +34164,7 @@
       </p:sp>
       <p:sp>
         <p:nvSpPr>
-          <p:cNvPr id="28" name="Text 26"/>
+          <p:cNvPr id="30" name="Text 28"/>
           <p:cNvSpPr/>
           <p:nvPr/>
         </p:nvSpPr>
@@ -34142,7 +34220,7 @@
       </p:sp>
       <p:sp>
         <p:nvSpPr>
-          <p:cNvPr id="29" name="Text 27"/>
+          <p:cNvPr id="31" name="Text 29"/>
           <p:cNvSpPr/>
           <p:nvPr/>
         </p:nvSpPr>
@@ -34198,7 +34276,7 @@
       </p:sp>
       <p:sp>
         <p:nvSpPr>
-          <p:cNvPr id="30" name="Text 28"/>
+          <p:cNvPr id="32" name="Text 30"/>
           <p:cNvSpPr/>
           <p:nvPr/>
         </p:nvSpPr>
@@ -34254,7 +34332,7 @@
       </p:sp>
       <p:sp>
         <p:nvSpPr>
-          <p:cNvPr id="31" name="Text 29"/>
+          <p:cNvPr id="33" name="Text 31"/>
           <p:cNvSpPr/>
           <p:nvPr/>
         </p:nvSpPr>
@@ -34310,7 +34388,7 @@
       </p:sp>
       <p:sp>
         <p:nvSpPr>
-          <p:cNvPr id="32" name="Text 30"/>
+          <p:cNvPr id="34" name="Text 32"/>
           <p:cNvSpPr/>
           <p:nvPr/>
         </p:nvSpPr>
@@ -34366,7 +34444,7 @@
       </p:sp>
       <p:sp>
         <p:nvSpPr>
-          <p:cNvPr id="33" name="Text 31"/>
+          <p:cNvPr id="35" name="Text 33"/>
           <p:cNvSpPr/>
           <p:nvPr/>
         </p:nvSpPr>
@@ -34422,7 +34500,7 @@
       </p:sp>
       <p:sp>
         <p:nvSpPr>
-          <p:cNvPr id="34" name="Text 32"/>
+          <p:cNvPr id="36" name="Text 34"/>
           <p:cNvSpPr/>
           <p:nvPr/>
         </p:nvSpPr>
@@ -34478,7 +34556,7 @@
       </p:sp>
       <p:sp>
         <p:nvSpPr>
-          <p:cNvPr id="35" name="Shape 33"/>
+          <p:cNvPr id="37" name="Shape 35"/>
           <p:cNvSpPr/>
           <p:nvPr/>
         </p:nvSpPr>
@@ -34501,7 +34579,7 @@
       </p:sp>
       <p:sp>
         <p:nvSpPr>
-          <p:cNvPr id="36" name="Text 34"/>
+          <p:cNvPr id="38" name="Text 36"/>
           <p:cNvSpPr/>
           <p:nvPr/>
         </p:nvSpPr>
@@ -34540,7 +34618,7 @@
       </p:sp>
       <p:sp>
         <p:nvSpPr>
-          <p:cNvPr id="37" name="Shape 35"/>
+          <p:cNvPr id="39" name="Shape 37"/>
           <p:cNvSpPr/>
           <p:nvPr/>
         </p:nvSpPr>
@@ -34563,7 +34641,7 @@
       </p:sp>
       <p:sp>
         <p:nvSpPr>
-          <p:cNvPr id="38" name="Text 36"/>
+          <p:cNvPr id="40" name="Text 38"/>
           <p:cNvSpPr/>
           <p:nvPr/>
         </p:nvSpPr>

</xml_diff>

<commit_message>
Folletos 2026-05 — generación automática
</commit_message>
<xml_diff>
--- a/folletos/2026-04/pptx/FIP_VANTRUST_LIQUIDEZ_ACTIVA.pptx
+++ b/folletos/2026-04/pptx/FIP_VANTRUST_LIQUIDEZ_ACTIVA.pptx
@@ -189,38 +189,50 @@
           </c:marker>
           <c:cat>
             <c:multiLvlStrRef>
-              <c:f>Sheet1!$A$2:$A$11</c:f>
+              <c:f>Sheet1!$A$2:$A$15</c:f>
               <c:multiLvlStrCache>
-                <c:ptCount val="10"/>
+                <c:ptCount val="14"/>
                 <c:lvl>
                   <c:pt idx="0">
+                    <c:v>Mar 2025</c:v>
+                  </c:pt>
+                  <c:pt idx="1">
+                    <c:v>Apr 2025</c:v>
+                  </c:pt>
+                  <c:pt idx="2">
+                    <c:v>May 2025</c:v>
+                  </c:pt>
+                  <c:pt idx="3">
+                    <c:v>Jun 2025</c:v>
+                  </c:pt>
+                  <c:pt idx="4">
                     <c:v>Jul 2025</c:v>
                   </c:pt>
-                  <c:pt idx="1">
+                  <c:pt idx="5">
                     <c:v>Aug 2025</c:v>
                   </c:pt>
-                  <c:pt idx="2">
+                  <c:pt idx="6">
                     <c:v>Sep 2025</c:v>
                   </c:pt>
-                  <c:pt idx="3">
+                  <c:pt idx="7">
                     <c:v>Oct 2025</c:v>
                   </c:pt>
-                  <c:pt idx="4">
+                  <c:pt idx="8">
                     <c:v>Nov 2025</c:v>
                   </c:pt>
-                  <c:pt idx="5">
+                  <c:pt idx="9">
                     <c:v>Dec 2025</c:v>
                   </c:pt>
-                  <c:pt idx="6">
+                  <c:pt idx="10">
                     <c:v>Jan 2026</c:v>
                   </c:pt>
-                  <c:pt idx="7">
+                  <c:pt idx="11">
                     <c:v>Feb 2026</c:v>
                   </c:pt>
-                  <c:pt idx="8">
+                  <c:pt idx="12">
                     <c:v>Mar 2026</c:v>
                   </c:pt>
-                  <c:pt idx="9">
+                  <c:pt idx="13">
                     <c:v>Apr 2026</c:v>
                   </c:pt>
                 </c:lvl>
@@ -229,39 +241,51 @@
           </c:cat>
           <c:val>
             <c:numRef>
-              <c:f>Sheet1!$B$2:$B$11</c:f>
+              <c:f>Sheet1!$B$2:$B$15</c:f>
               <c:numCache>
                 <c:formatCode>General</c:formatCode>
-                <c:ptCount val="10"/>
+                <c:ptCount val="14"/>
                 <c:pt idx="0">
                   <c:v>100</c:v>
                 </c:pt>
                 <c:pt idx="1">
-                  <c:v>100.4</c:v>
+                  <c:v>100.42</c:v>
                 </c:pt>
                 <c:pt idx="2">
-                  <c:v>100.79</c:v>
+                  <c:v>100.84</c:v>
                 </c:pt>
                 <c:pt idx="3">
-                  <c:v>101.19</c:v>
+                  <c:v>101.27</c:v>
                 </c:pt>
                 <c:pt idx="4">
-                  <c:v>101.59</c:v>
+                  <c:v>101.71</c:v>
                 </c:pt>
                 <c:pt idx="5">
-                  <c:v>101.98</c:v>
+                  <c:v>102.1</c:v>
                 </c:pt>
                 <c:pt idx="6">
-                  <c:v>102.37</c:v>
+                  <c:v>102.53</c:v>
                 </c:pt>
                 <c:pt idx="7">
-                  <c:v>102.75</c:v>
+                  <c:v>102.94</c:v>
                 </c:pt>
                 <c:pt idx="8">
-                  <c:v>103.14</c:v>
+                  <c:v>103.33</c:v>
                 </c:pt>
                 <c:pt idx="9">
-                  <c:v>103.52</c:v>
+                  <c:v>103.76</c:v>
+                </c:pt>
+                <c:pt idx="10">
+                  <c:v>104.16</c:v>
+                </c:pt>
+                <c:pt idx="11">
+                  <c:v>104.54</c:v>
+                </c:pt>
+                <c:pt idx="12">
+                  <c:v>104.95</c:v>
+                </c:pt>
+                <c:pt idx="13">
+                  <c:v>105.34</c:v>
                 </c:pt>
               </c:numCache>
             </c:numRef>
@@ -339,38 +363,50 @@
           </c:marker>
           <c:cat>
             <c:multiLvlStrRef>
-              <c:f>Sheet1!$A$2:$A$11</c:f>
+              <c:f>Sheet1!$A$2:$A$15</c:f>
               <c:multiLvlStrCache>
-                <c:ptCount val="10"/>
+                <c:ptCount val="14"/>
                 <c:lvl>
                   <c:pt idx="0">
+                    <c:v>Mar 2025</c:v>
+                  </c:pt>
+                  <c:pt idx="1">
+                    <c:v>Apr 2025</c:v>
+                  </c:pt>
+                  <c:pt idx="2">
+                    <c:v>May 2025</c:v>
+                  </c:pt>
+                  <c:pt idx="3">
+                    <c:v>Jun 2025</c:v>
+                  </c:pt>
+                  <c:pt idx="4">
                     <c:v>Jul 2025</c:v>
                   </c:pt>
-                  <c:pt idx="1">
+                  <c:pt idx="5">
                     <c:v>Aug 2025</c:v>
                   </c:pt>
-                  <c:pt idx="2">
+                  <c:pt idx="6">
                     <c:v>Sep 2025</c:v>
                   </c:pt>
-                  <c:pt idx="3">
+                  <c:pt idx="7">
                     <c:v>Oct 2025</c:v>
                   </c:pt>
-                  <c:pt idx="4">
+                  <c:pt idx="8">
                     <c:v>Nov 2025</c:v>
                   </c:pt>
-                  <c:pt idx="5">
+                  <c:pt idx="9">
                     <c:v>Dec 2025</c:v>
                   </c:pt>
-                  <c:pt idx="6">
+                  <c:pt idx="10">
                     <c:v>Jan 2026</c:v>
                   </c:pt>
-                  <c:pt idx="7">
+                  <c:pt idx="11">
                     <c:v>Feb 2026</c:v>
                   </c:pt>
-                  <c:pt idx="8">
+                  <c:pt idx="12">
                     <c:v>Mar 2026</c:v>
                   </c:pt>
-                  <c:pt idx="9">
+                  <c:pt idx="13">
                     <c:v>Apr 2026</c:v>
                   </c:pt>
                 </c:lvl>
@@ -379,39 +415,51 @@
           </c:cat>
           <c:val>
             <c:numRef>
-              <c:f>Sheet1!$C$2:$C$11</c:f>
+              <c:f>Sheet1!$C$2:$C$15</c:f>
               <c:numCache>
                 <c:formatCode>General</c:formatCode>
-                <c:ptCount val="10"/>
+                <c:ptCount val="14"/>
                 <c:pt idx="0">
                   <c:v>100</c:v>
                 </c:pt>
                 <c:pt idx="1">
-                  <c:v>100.61</c:v>
+                  <c:v>100.1</c:v>
                 </c:pt>
                 <c:pt idx="2">
-                  <c:v>101.19</c:v>
+                  <c:v>100.19</c:v>
                 </c:pt>
                 <c:pt idx="3">
-                  <c:v>101.85</c:v>
+                  <c:v>100.92</c:v>
                 </c:pt>
                 <c:pt idx="4">
-                  <c:v>102.44</c:v>
+                  <c:v>101.55</c:v>
                 </c:pt>
                 <c:pt idx="5">
-                  <c:v>103.09</c:v>
+                  <c:v>102.17</c:v>
                 </c:pt>
                 <c:pt idx="6">
-                  <c:v>103.69</c:v>
+                  <c:v>102.76</c:v>
                 </c:pt>
                 <c:pt idx="7">
-                  <c:v>104.27</c:v>
+                  <c:v>103.43</c:v>
                 </c:pt>
                 <c:pt idx="8">
-                  <c:v>104.91</c:v>
+                  <c:v>104.03</c:v>
                 </c:pt>
                 <c:pt idx="9">
-                  <c:v>105.53</c:v>
+                  <c:v>104.68</c:v>
+                </c:pt>
+                <c:pt idx="10">
+                  <c:v>105.3</c:v>
+                </c:pt>
+                <c:pt idx="11">
+                  <c:v>105.88</c:v>
+                </c:pt>
+                <c:pt idx="12">
+                  <c:v>106.53</c:v>
+                </c:pt>
+                <c:pt idx="13">
+                  <c:v>107.17</c:v>
                 </c:pt>
               </c:numCache>
             </c:numRef>
@@ -489,38 +537,50 @@
           </c:marker>
           <c:cat>
             <c:multiLvlStrRef>
-              <c:f>Sheet1!$A$2:$A$11</c:f>
+              <c:f>Sheet1!$A$2:$A$15</c:f>
               <c:multiLvlStrCache>
-                <c:ptCount val="10"/>
+                <c:ptCount val="14"/>
                 <c:lvl>
                   <c:pt idx="0">
+                    <c:v>Mar 2025</c:v>
+                  </c:pt>
+                  <c:pt idx="1">
+                    <c:v>Apr 2025</c:v>
+                  </c:pt>
+                  <c:pt idx="2">
+                    <c:v>May 2025</c:v>
+                  </c:pt>
+                  <c:pt idx="3">
+                    <c:v>Jun 2025</c:v>
+                  </c:pt>
+                  <c:pt idx="4">
                     <c:v>Jul 2025</c:v>
                   </c:pt>
-                  <c:pt idx="1">
+                  <c:pt idx="5">
                     <c:v>Aug 2025</c:v>
                   </c:pt>
-                  <c:pt idx="2">
+                  <c:pt idx="6">
                     <c:v>Sep 2025</c:v>
                   </c:pt>
-                  <c:pt idx="3">
+                  <c:pt idx="7">
                     <c:v>Oct 2025</c:v>
                   </c:pt>
-                  <c:pt idx="4">
+                  <c:pt idx="8">
                     <c:v>Nov 2025</c:v>
                   </c:pt>
-                  <c:pt idx="5">
+                  <c:pt idx="9">
                     <c:v>Dec 2025</c:v>
                   </c:pt>
-                  <c:pt idx="6">
+                  <c:pt idx="10">
                     <c:v>Jan 2026</c:v>
                   </c:pt>
-                  <c:pt idx="7">
+                  <c:pt idx="11">
                     <c:v>Feb 2026</c:v>
                   </c:pt>
-                  <c:pt idx="8">
+                  <c:pt idx="12">
                     <c:v>Mar 2026</c:v>
                   </c:pt>
-                  <c:pt idx="9">
+                  <c:pt idx="13">
                     <c:v>Apr 2026</c:v>
                   </c:pt>
                 </c:lvl>
@@ -529,10 +589,10 @@
           </c:cat>
           <c:val>
             <c:numRef>
-              <c:f>Sheet1!$D$2:$D$11</c:f>
+              <c:f>Sheet1!$D$2:$D$15</c:f>
               <c:numCache>
                 <c:formatCode>General</c:formatCode>
-                <c:ptCount val="10"/>
+                <c:ptCount val="14"/>
                 <c:pt idx="0">
                   <c:v>100</c:v>
                 </c:pt>
@@ -540,28 +600,40 @@
                   <c:v>100.3</c:v>
                 </c:pt>
                 <c:pt idx="2">
-                  <c:v>100.58</c:v>
+                  <c:v>100.61</c:v>
                 </c:pt>
                 <c:pt idx="3">
-                  <c:v>100.87</c:v>
+                  <c:v>100.91</c:v>
                 </c:pt>
                 <c:pt idx="4">
-                  <c:v>101.15</c:v>
+                  <c:v>101.22</c:v>
                 </c:pt>
                 <c:pt idx="5">
-                  <c:v>101.71</c:v>
+                  <c:v>101.51</c:v>
                 </c:pt>
                 <c:pt idx="6">
-                  <c:v>101.71</c:v>
+                  <c:v>101.79</c:v>
                 </c:pt>
                 <c:pt idx="7">
-                  <c:v>101.96</c:v>
+                  <c:v>102.08</c:v>
                 </c:pt>
                 <c:pt idx="8">
-                  <c:v>102.23</c:v>
+                  <c:v>102.37</c:v>
                 </c:pt>
                 <c:pt idx="9">
-                  <c:v>102.5</c:v>
+                  <c:v>102.66</c:v>
+                </c:pt>
+                <c:pt idx="10">
+                  <c:v>102.94</c:v>
+                </c:pt>
+                <c:pt idx="11">
+                  <c:v>103.19</c:v>
+                </c:pt>
+                <c:pt idx="12">
+                  <c:v>103.47</c:v>
+                </c:pt>
+                <c:pt idx="13">
+                  <c:v>103.74</c:v>
                 </c:pt>
               </c:numCache>
             </c:numRef>
@@ -3113,7 +3185,7 @@
                 <a:ea typeface="Calibri" pitchFamily="34" charset="-122"/>
                 <a:cs typeface="Calibri" pitchFamily="34" charset="-120"/>
               </a:rPr>
-              <a:t>prueba 13 CLP</a:t>
+              <a:t>prueba CLP</a:t>
             </a:r>
             <a:endParaRPr lang="en-US" sz="800" dirty="0"/>
           </a:p>
@@ -3762,7 +3834,7 @@
                           <a:ea typeface="Calibri" pitchFamily="34" charset="-122"/>
                           <a:cs typeface="Calibri" pitchFamily="34" charset="-120"/>
                         </a:rPr>
-                        <a:t>0.37%</a:t>
+                        <a:t>0.38%</a:t>
                       </a:r>
                       <a:endParaRPr lang="en-US" sz="750" dirty="0">
                         <a:latin typeface="Calibri" charset="0"/>
@@ -3898,7 +3970,7 @@
                           <a:ea typeface="Calibri" pitchFamily="34" charset="-122"/>
                           <a:cs typeface="Calibri" pitchFamily="34" charset="-120"/>
                         </a:rPr>
-                        <a:t>2.30%</a:t>
+                        <a:t>2.33%</a:t>
                       </a:r>
                       <a:endParaRPr lang="en-US" sz="750" dirty="0">
                         <a:latin typeface="Calibri" charset="0"/>
@@ -3966,7 +4038,7 @@
                           <a:ea typeface="Calibri" pitchFamily="34" charset="-122"/>
                           <a:cs typeface="Calibri" pitchFamily="34" charset="-120"/>
                         </a:rPr>
-                        <a:t>4.82%</a:t>
+                        <a:t>—</a:t>
                       </a:r>
                       <a:endParaRPr lang="en-US" sz="750" dirty="0">
                         <a:latin typeface="Calibri" charset="0"/>
@@ -4376,7 +4448,7 @@
                           <a:ea typeface="Calibri" pitchFamily="34" charset="-122"/>
                           <a:cs typeface="Calibri" pitchFamily="34" charset="-120"/>
                         </a:rPr>
-                        <a:t>3.43%</a:t>
+                        <a:t>—</a:t>
                       </a:r>
                       <a:endParaRPr lang="en-US" sz="750" dirty="0">
                         <a:latin typeface="Calibri" charset="0"/>
@@ -4996,20 +5068,20 @@
               <a:tblPr/>
               <a:tblGrid>
                 <a:gridCol w="201168"/>
-                <a:gridCol w="822960"/>
-                <a:gridCol w="246888"/>
-                <a:gridCol w="246888"/>
-                <a:gridCol w="246888"/>
-                <a:gridCol w="246888"/>
-                <a:gridCol w="246888"/>
-                <a:gridCol w="246888"/>
-                <a:gridCol w="246888"/>
-                <a:gridCol w="246888"/>
-                <a:gridCol w="246888"/>
-                <a:gridCol w="246888"/>
-                <a:gridCol w="246888"/>
-                <a:gridCol w="246888"/>
-                <a:gridCol w="283464"/>
+                <a:gridCol w="804672"/>
+                <a:gridCol w="292608"/>
+                <a:gridCol w="292608"/>
+                <a:gridCol w="292608"/>
+                <a:gridCol w="292608"/>
+                <a:gridCol w="292608"/>
+                <a:gridCol w="292608"/>
+                <a:gridCol w="292608"/>
+                <a:gridCol w="292608"/>
+                <a:gridCol w="292608"/>
+                <a:gridCol w="292608"/>
+                <a:gridCol w="292608"/>
+                <a:gridCol w="292608"/>
+                <a:gridCol w="301752"/>
               </a:tblGrid>
               <a:tr h="123444">
                 <a:tc>
@@ -6157,7 +6229,137 @@
                           <a:ea typeface="Calibri" pitchFamily="34" charset="-122"/>
                           <a:cs typeface="Calibri" pitchFamily="34" charset="-120"/>
                         </a:rPr>
-                        <a:t>0.42%</a:t>
+                        <a:t>0.45%</a:t>
+                      </a:r>
+                      <a:endParaRPr lang="en-US" sz="500" dirty="0">
+                        <a:latin typeface="Calibri" charset="0"/>
+                        <a:ea typeface="Calibri" charset="0"/>
+                        <a:cs typeface="Calibri" charset="0"/>
+                      </a:endParaRPr>
+                    </a:p>
+                  </a:txBody>
+                  <a:tcPr marL="91440" marR="91440" marT="45720" marB="45720">
+                    <a:lnL w="2540" cap="flat" cmpd="sng" algn="ctr">
+                      <a:solidFill>
+                        <a:srgbClr val="EEEEEE"/>
+                      </a:solidFill>
+                      <a:prstDash val="solid"/>
+                      <a:round/>
+                      <a:headEnd type="none" w="med" len="med"/>
+                      <a:tailEnd type="none" w="med" len="med"/>
+                    </a:lnL>
+                    <a:lnR w="2540" cap="flat" cmpd="sng" algn="ctr">
+                      <a:solidFill>
+                        <a:srgbClr val="EEEEEE"/>
+                      </a:solidFill>
+                      <a:prstDash val="solid"/>
+                      <a:round/>
+                      <a:headEnd type="none" w="med" len="med"/>
+                      <a:tailEnd type="none" w="med" len="med"/>
+                    </a:lnR>
+                    <a:lnT w="2540" cap="flat" cmpd="sng" algn="ctr">
+                      <a:solidFill>
+                        <a:srgbClr val="EEEEEE"/>
+                      </a:solidFill>
+                      <a:prstDash val="solid"/>
+                      <a:round/>
+                      <a:headEnd type="none" w="med" len="med"/>
+                      <a:tailEnd type="none" w="med" len="med"/>
+                    </a:lnT>
+                    <a:lnB w="2540" cap="flat" cmpd="sng" algn="ctr">
+                      <a:solidFill>
+                        <a:srgbClr val="EEEEEE"/>
+                      </a:solidFill>
+                      <a:prstDash val="solid"/>
+                      <a:round/>
+                      <a:headEnd type="none" w="med" len="med"/>
+                      <a:tailEnd type="none" w="med" len="med"/>
+                    </a:lnB>
+                  </a:tcPr>
+                </a:tc>
+                <a:tc>
+                  <a:txBody>
+                    <a:bodyPr/>
+                    <a:lstStyle/>
+                    <a:p>
+                      <a:pPr algn="ctr" indent="0" marL="0">
+                        <a:buNone/>
+                      </a:pPr>
+                      <a:r>
+                        <a:rPr lang="en-US" sz="500" dirty="0">
+                          <a:solidFill>
+                            <a:srgbClr val="777777"/>
+                          </a:solidFill>
+                          <a:latin typeface="Calibri" pitchFamily="34" charset="0"/>
+                          <a:ea typeface="Calibri" pitchFamily="34" charset="-122"/>
+                          <a:cs typeface="Calibri" pitchFamily="34" charset="-120"/>
+                        </a:rPr>
+                        <a:t>0.39%</a:t>
+                      </a:r>
+                      <a:endParaRPr lang="en-US" sz="500" dirty="0">
+                        <a:latin typeface="Calibri" charset="0"/>
+                        <a:ea typeface="Calibri" charset="0"/>
+                        <a:cs typeface="Calibri" charset="0"/>
+                      </a:endParaRPr>
+                    </a:p>
+                  </a:txBody>
+                  <a:tcPr marL="91440" marR="91440" marT="45720" marB="45720">
+                    <a:lnL w="2540" cap="flat" cmpd="sng" algn="ctr">
+                      <a:solidFill>
+                        <a:srgbClr val="EEEEEE"/>
+                      </a:solidFill>
+                      <a:prstDash val="solid"/>
+                      <a:round/>
+                      <a:headEnd type="none" w="med" len="med"/>
+                      <a:tailEnd type="none" w="med" len="med"/>
+                    </a:lnL>
+                    <a:lnR w="2540" cap="flat" cmpd="sng" algn="ctr">
+                      <a:solidFill>
+                        <a:srgbClr val="EEEEEE"/>
+                      </a:solidFill>
+                      <a:prstDash val="solid"/>
+                      <a:round/>
+                      <a:headEnd type="none" w="med" len="med"/>
+                      <a:tailEnd type="none" w="med" len="med"/>
+                    </a:lnR>
+                    <a:lnT w="2540" cap="flat" cmpd="sng" algn="ctr">
+                      <a:solidFill>
+                        <a:srgbClr val="EEEEEE"/>
+                      </a:solidFill>
+                      <a:prstDash val="solid"/>
+                      <a:round/>
+                      <a:headEnd type="none" w="med" len="med"/>
+                      <a:tailEnd type="none" w="med" len="med"/>
+                    </a:lnT>
+                    <a:lnB w="2540" cap="flat" cmpd="sng" algn="ctr">
+                      <a:solidFill>
+                        <a:srgbClr val="EEEEEE"/>
+                      </a:solidFill>
+                      <a:prstDash val="solid"/>
+                      <a:round/>
+                      <a:headEnd type="none" w="med" len="med"/>
+                      <a:tailEnd type="none" w="med" len="med"/>
+                    </a:lnB>
+                  </a:tcPr>
+                </a:tc>
+                <a:tc>
+                  <a:txBody>
+                    <a:bodyPr/>
+                    <a:lstStyle/>
+                    <a:p>
+                      <a:pPr algn="ctr" indent="0" marL="0">
+                        <a:buNone/>
+                      </a:pPr>
+                      <a:r>
+                        <a:rPr lang="en-US" sz="500" dirty="0">
+                          <a:solidFill>
+                            <a:srgbClr val="777777"/>
+                          </a:solidFill>
+                          <a:latin typeface="Calibri" pitchFamily="34" charset="0"/>
+                          <a:ea typeface="Calibri" pitchFamily="34" charset="-122"/>
+                          <a:cs typeface="Calibri" pitchFamily="34" charset="-120"/>
+                        </a:rPr>
+                        <a:t>0.43%</a:t>
                       </a:r>
                       <a:endParaRPr lang="en-US" sz="500" dirty="0">
                         <a:latin typeface="Calibri" charset="0"/>
@@ -6352,7 +6554,137 @@
                           <a:ea typeface="Calibri" pitchFamily="34" charset="-122"/>
                           <a:cs typeface="Calibri" pitchFamily="34" charset="-120"/>
                         </a:rPr>
-                        <a:t>0.42%</a:t>
+                        <a:t>0.43%</a:t>
+                      </a:r>
+                      <a:endParaRPr lang="en-US" sz="500" dirty="0">
+                        <a:latin typeface="Calibri" charset="0"/>
+                        <a:ea typeface="Calibri" charset="0"/>
+                        <a:cs typeface="Calibri" charset="0"/>
+                      </a:endParaRPr>
+                    </a:p>
+                  </a:txBody>
+                  <a:tcPr marL="91440" marR="91440" marT="45720" marB="45720">
+                    <a:lnL w="2540" cap="flat" cmpd="sng" algn="ctr">
+                      <a:solidFill>
+                        <a:srgbClr val="EEEEEE"/>
+                      </a:solidFill>
+                      <a:prstDash val="solid"/>
+                      <a:round/>
+                      <a:headEnd type="none" w="med" len="med"/>
+                      <a:tailEnd type="none" w="med" len="med"/>
+                    </a:lnL>
+                    <a:lnR w="2540" cap="flat" cmpd="sng" algn="ctr">
+                      <a:solidFill>
+                        <a:srgbClr val="EEEEEE"/>
+                      </a:solidFill>
+                      <a:prstDash val="solid"/>
+                      <a:round/>
+                      <a:headEnd type="none" w="med" len="med"/>
+                      <a:tailEnd type="none" w="med" len="med"/>
+                    </a:lnR>
+                    <a:lnT w="2540" cap="flat" cmpd="sng" algn="ctr">
+                      <a:solidFill>
+                        <a:srgbClr val="EEEEEE"/>
+                      </a:solidFill>
+                      <a:prstDash val="solid"/>
+                      <a:round/>
+                      <a:headEnd type="none" w="med" len="med"/>
+                      <a:tailEnd type="none" w="med" len="med"/>
+                    </a:lnT>
+                    <a:lnB w="2540" cap="flat" cmpd="sng" algn="ctr">
+                      <a:solidFill>
+                        <a:srgbClr val="EEEEEE"/>
+                      </a:solidFill>
+                      <a:prstDash val="solid"/>
+                      <a:round/>
+                      <a:headEnd type="none" w="med" len="med"/>
+                      <a:tailEnd type="none" w="med" len="med"/>
+                    </a:lnB>
+                  </a:tcPr>
+                </a:tc>
+                <a:tc>
+                  <a:txBody>
+                    <a:bodyPr/>
+                    <a:lstStyle/>
+                    <a:p>
+                      <a:pPr algn="ctr" indent="0" marL="0">
+                        <a:buNone/>
+                      </a:pPr>
+                      <a:r>
+                        <a:rPr lang="en-US" sz="500" dirty="0">
+                          <a:solidFill>
+                            <a:srgbClr val="777777"/>
+                          </a:solidFill>
+                          <a:latin typeface="Calibri" pitchFamily="34" charset="0"/>
+                          <a:ea typeface="Calibri" pitchFamily="34" charset="-122"/>
+                          <a:cs typeface="Calibri" pitchFamily="34" charset="-120"/>
+                        </a:rPr>
+                        <a:t>0.43%</a:t>
+                      </a:r>
+                      <a:endParaRPr lang="en-US" sz="500" dirty="0">
+                        <a:latin typeface="Calibri" charset="0"/>
+                        <a:ea typeface="Calibri" charset="0"/>
+                        <a:cs typeface="Calibri" charset="0"/>
+                      </a:endParaRPr>
+                    </a:p>
+                  </a:txBody>
+                  <a:tcPr marL="91440" marR="91440" marT="45720" marB="45720">
+                    <a:lnL w="2540" cap="flat" cmpd="sng" algn="ctr">
+                      <a:solidFill>
+                        <a:srgbClr val="EEEEEE"/>
+                      </a:solidFill>
+                      <a:prstDash val="solid"/>
+                      <a:round/>
+                      <a:headEnd type="none" w="med" len="med"/>
+                      <a:tailEnd type="none" w="med" len="med"/>
+                    </a:lnL>
+                    <a:lnR w="2540" cap="flat" cmpd="sng" algn="ctr">
+                      <a:solidFill>
+                        <a:srgbClr val="EEEEEE"/>
+                      </a:solidFill>
+                      <a:prstDash val="solid"/>
+                      <a:round/>
+                      <a:headEnd type="none" w="med" len="med"/>
+                      <a:tailEnd type="none" w="med" len="med"/>
+                    </a:lnR>
+                    <a:lnT w="2540" cap="flat" cmpd="sng" algn="ctr">
+                      <a:solidFill>
+                        <a:srgbClr val="EEEEEE"/>
+                      </a:solidFill>
+                      <a:prstDash val="solid"/>
+                      <a:round/>
+                      <a:headEnd type="none" w="med" len="med"/>
+                      <a:tailEnd type="none" w="med" len="med"/>
+                    </a:lnT>
+                    <a:lnB w="2540" cap="flat" cmpd="sng" algn="ctr">
+                      <a:solidFill>
+                        <a:srgbClr val="EEEEEE"/>
+                      </a:solidFill>
+                      <a:prstDash val="solid"/>
+                      <a:round/>
+                      <a:headEnd type="none" w="med" len="med"/>
+                      <a:tailEnd type="none" w="med" len="med"/>
+                    </a:lnB>
+                  </a:tcPr>
+                </a:tc>
+                <a:tc>
+                  <a:txBody>
+                    <a:bodyPr/>
+                    <a:lstStyle/>
+                    <a:p>
+                      <a:pPr algn="ctr" indent="0" marL="0">
+                        <a:buNone/>
+                      </a:pPr>
+                      <a:r>
+                        <a:rPr lang="en-US" sz="500" dirty="0">
+                          <a:solidFill>
+                            <a:srgbClr val="777777"/>
+                          </a:solidFill>
+                          <a:latin typeface="Calibri" pitchFamily="34" charset="0"/>
+                          <a:ea typeface="Calibri" pitchFamily="34" charset="-122"/>
+                          <a:cs typeface="Calibri" pitchFamily="34" charset="-120"/>
+                        </a:rPr>
+                        <a:t>0.38%</a:t>
                       </a:r>
                       <a:endParaRPr lang="en-US" sz="500" dirty="0">
                         <a:latin typeface="Calibri" charset="0"/>
@@ -6482,7 +6814,72 @@
                           <a:ea typeface="Calibri" pitchFamily="34" charset="-122"/>
                           <a:cs typeface="Calibri" pitchFamily="34" charset="-120"/>
                         </a:rPr>
-                        <a:t>0.42%</a:t>
+                        <a:t>0.40%</a:t>
+                      </a:r>
+                      <a:endParaRPr lang="en-US" sz="500" dirty="0">
+                        <a:latin typeface="Calibri" charset="0"/>
+                        <a:ea typeface="Calibri" charset="0"/>
+                        <a:cs typeface="Calibri" charset="0"/>
+                      </a:endParaRPr>
+                    </a:p>
+                  </a:txBody>
+                  <a:tcPr marL="91440" marR="91440" marT="45720" marB="45720">
+                    <a:lnL w="2540" cap="flat" cmpd="sng" algn="ctr">
+                      <a:solidFill>
+                        <a:srgbClr val="EEEEEE"/>
+                      </a:solidFill>
+                      <a:prstDash val="solid"/>
+                      <a:round/>
+                      <a:headEnd type="none" w="med" len="med"/>
+                      <a:tailEnd type="none" w="med" len="med"/>
+                    </a:lnL>
+                    <a:lnR w="2540" cap="flat" cmpd="sng" algn="ctr">
+                      <a:solidFill>
+                        <a:srgbClr val="EEEEEE"/>
+                      </a:solidFill>
+                      <a:prstDash val="solid"/>
+                      <a:round/>
+                      <a:headEnd type="none" w="med" len="med"/>
+                      <a:tailEnd type="none" w="med" len="med"/>
+                    </a:lnR>
+                    <a:lnT w="2540" cap="flat" cmpd="sng" algn="ctr">
+                      <a:solidFill>
+                        <a:srgbClr val="EEEEEE"/>
+                      </a:solidFill>
+                      <a:prstDash val="solid"/>
+                      <a:round/>
+                      <a:headEnd type="none" w="med" len="med"/>
+                      <a:tailEnd type="none" w="med" len="med"/>
+                    </a:lnT>
+                    <a:lnB w="2540" cap="flat" cmpd="sng" algn="ctr">
+                      <a:solidFill>
+                        <a:srgbClr val="EEEEEE"/>
+                      </a:solidFill>
+                      <a:prstDash val="solid"/>
+                      <a:round/>
+                      <a:headEnd type="none" w="med" len="med"/>
+                      <a:tailEnd type="none" w="med" len="med"/>
+                    </a:lnB>
+                  </a:tcPr>
+                </a:tc>
+                <a:tc>
+                  <a:txBody>
+                    <a:bodyPr/>
+                    <a:lstStyle/>
+                    <a:p>
+                      <a:pPr algn="ctr" indent="0" marL="0">
+                        <a:buNone/>
+                      </a:pPr>
+                      <a:r>
+                        <a:rPr lang="en-US" sz="500" dirty="0">
+                          <a:solidFill>
+                            <a:srgbClr val="777777"/>
+                          </a:solidFill>
+                          <a:latin typeface="Calibri" pitchFamily="34" charset="0"/>
+                          <a:ea typeface="Calibri" pitchFamily="34" charset="-122"/>
+                          <a:cs typeface="Calibri" pitchFamily="34" charset="-120"/>
+                        </a:rPr>
+                        <a:t>0.38%</a:t>
                       </a:r>
                       <a:endParaRPr lang="en-US" sz="500" dirty="0">
                         <a:latin typeface="Calibri" charset="0"/>
@@ -6604,331 +7001,6 @@
                         <a:buNone/>
                       </a:pPr>
                       <a:r>
-                        <a:rPr lang="en-US" sz="500" dirty="0">
-                          <a:solidFill>
-                            <a:srgbClr val="777777"/>
-                          </a:solidFill>
-                          <a:latin typeface="Calibri" pitchFamily="34" charset="0"/>
-                          <a:ea typeface="Calibri" pitchFamily="34" charset="-122"/>
-                          <a:cs typeface="Calibri" pitchFamily="34" charset="-120"/>
-                        </a:rPr>
-                        <a:t>0.40%</a:t>
-                      </a:r>
-                      <a:endParaRPr lang="en-US" sz="500" dirty="0">
-                        <a:latin typeface="Calibri" charset="0"/>
-                        <a:ea typeface="Calibri" charset="0"/>
-                        <a:cs typeface="Calibri" charset="0"/>
-                      </a:endParaRPr>
-                    </a:p>
-                  </a:txBody>
-                  <a:tcPr marL="91440" marR="91440" marT="45720" marB="45720">
-                    <a:lnL w="2540" cap="flat" cmpd="sng" algn="ctr">
-                      <a:solidFill>
-                        <a:srgbClr val="EEEEEE"/>
-                      </a:solidFill>
-                      <a:prstDash val="solid"/>
-                      <a:round/>
-                      <a:headEnd type="none" w="med" len="med"/>
-                      <a:tailEnd type="none" w="med" len="med"/>
-                    </a:lnL>
-                    <a:lnR w="2540" cap="flat" cmpd="sng" algn="ctr">
-                      <a:solidFill>
-                        <a:srgbClr val="EEEEEE"/>
-                      </a:solidFill>
-                      <a:prstDash val="solid"/>
-                      <a:round/>
-                      <a:headEnd type="none" w="med" len="med"/>
-                      <a:tailEnd type="none" w="med" len="med"/>
-                    </a:lnR>
-                    <a:lnT w="2540" cap="flat" cmpd="sng" algn="ctr">
-                      <a:solidFill>
-                        <a:srgbClr val="EEEEEE"/>
-                      </a:solidFill>
-                      <a:prstDash val="solid"/>
-                      <a:round/>
-                      <a:headEnd type="none" w="med" len="med"/>
-                      <a:tailEnd type="none" w="med" len="med"/>
-                    </a:lnT>
-                    <a:lnB w="2540" cap="flat" cmpd="sng" algn="ctr">
-                      <a:solidFill>
-                        <a:srgbClr val="EEEEEE"/>
-                      </a:solidFill>
-                      <a:prstDash val="solid"/>
-                      <a:round/>
-                      <a:headEnd type="none" w="med" len="med"/>
-                      <a:tailEnd type="none" w="med" len="med"/>
-                    </a:lnB>
-                  </a:tcPr>
-                </a:tc>
-                <a:tc>
-                  <a:txBody>
-                    <a:bodyPr/>
-                    <a:lstStyle/>
-                    <a:p>
-                      <a:pPr algn="ctr" indent="0" marL="0">
-                        <a:buNone/>
-                      </a:pPr>
-                      <a:r>
-                        <a:rPr lang="en-US" sz="500" dirty="0">
-                          <a:solidFill>
-                            <a:srgbClr val="777777"/>
-                          </a:solidFill>
-                          <a:latin typeface="Calibri" pitchFamily="34" charset="0"/>
-                          <a:ea typeface="Calibri" pitchFamily="34" charset="-122"/>
-                          <a:cs typeface="Calibri" pitchFamily="34" charset="-120"/>
-                        </a:rPr>
-                        <a:t>0.40%</a:t>
-                      </a:r>
-                      <a:endParaRPr lang="en-US" sz="500" dirty="0">
-                        <a:latin typeface="Calibri" charset="0"/>
-                        <a:ea typeface="Calibri" charset="0"/>
-                        <a:cs typeface="Calibri" charset="0"/>
-                      </a:endParaRPr>
-                    </a:p>
-                  </a:txBody>
-                  <a:tcPr marL="91440" marR="91440" marT="45720" marB="45720">
-                    <a:lnL w="2540" cap="flat" cmpd="sng" algn="ctr">
-                      <a:solidFill>
-                        <a:srgbClr val="EEEEEE"/>
-                      </a:solidFill>
-                      <a:prstDash val="solid"/>
-                      <a:round/>
-                      <a:headEnd type="none" w="med" len="med"/>
-                      <a:tailEnd type="none" w="med" len="med"/>
-                    </a:lnL>
-                    <a:lnR w="2540" cap="flat" cmpd="sng" algn="ctr">
-                      <a:solidFill>
-                        <a:srgbClr val="EEEEEE"/>
-                      </a:solidFill>
-                      <a:prstDash val="solid"/>
-                      <a:round/>
-                      <a:headEnd type="none" w="med" len="med"/>
-                      <a:tailEnd type="none" w="med" len="med"/>
-                    </a:lnR>
-                    <a:lnT w="2540" cap="flat" cmpd="sng" algn="ctr">
-                      <a:solidFill>
-                        <a:srgbClr val="EEEEEE"/>
-                      </a:solidFill>
-                      <a:prstDash val="solid"/>
-                      <a:round/>
-                      <a:headEnd type="none" w="med" len="med"/>
-                      <a:tailEnd type="none" w="med" len="med"/>
-                    </a:lnT>
-                    <a:lnB w="2540" cap="flat" cmpd="sng" algn="ctr">
-                      <a:solidFill>
-                        <a:srgbClr val="EEEEEE"/>
-                      </a:solidFill>
-                      <a:prstDash val="solid"/>
-                      <a:round/>
-                      <a:headEnd type="none" w="med" len="med"/>
-                      <a:tailEnd type="none" w="med" len="med"/>
-                    </a:lnB>
-                  </a:tcPr>
-                </a:tc>
-                <a:tc>
-                  <a:txBody>
-                    <a:bodyPr/>
-                    <a:lstStyle/>
-                    <a:p>
-                      <a:pPr algn="ctr" indent="0" marL="0">
-                        <a:buNone/>
-                      </a:pPr>
-                      <a:r>
-                        <a:rPr lang="en-US" sz="500" dirty="0">
-                          <a:solidFill>
-                            <a:srgbClr val="777777"/>
-                          </a:solidFill>
-                          <a:latin typeface="Calibri" pitchFamily="34" charset="0"/>
-                          <a:ea typeface="Calibri" pitchFamily="34" charset="-122"/>
-                          <a:cs typeface="Calibri" pitchFamily="34" charset="-120"/>
-                        </a:rPr>
-                        <a:t>0.40%</a:t>
-                      </a:r>
-                      <a:endParaRPr lang="en-US" sz="500" dirty="0">
-                        <a:latin typeface="Calibri" charset="0"/>
-                        <a:ea typeface="Calibri" charset="0"/>
-                        <a:cs typeface="Calibri" charset="0"/>
-                      </a:endParaRPr>
-                    </a:p>
-                  </a:txBody>
-                  <a:tcPr marL="91440" marR="91440" marT="45720" marB="45720">
-                    <a:lnL w="2540" cap="flat" cmpd="sng" algn="ctr">
-                      <a:solidFill>
-                        <a:srgbClr val="EEEEEE"/>
-                      </a:solidFill>
-                      <a:prstDash val="solid"/>
-                      <a:round/>
-                      <a:headEnd type="none" w="med" len="med"/>
-                      <a:tailEnd type="none" w="med" len="med"/>
-                    </a:lnL>
-                    <a:lnR w="2540" cap="flat" cmpd="sng" algn="ctr">
-                      <a:solidFill>
-                        <a:srgbClr val="EEEEEE"/>
-                      </a:solidFill>
-                      <a:prstDash val="solid"/>
-                      <a:round/>
-                      <a:headEnd type="none" w="med" len="med"/>
-                      <a:tailEnd type="none" w="med" len="med"/>
-                    </a:lnR>
-                    <a:lnT w="2540" cap="flat" cmpd="sng" algn="ctr">
-                      <a:solidFill>
-                        <a:srgbClr val="EEEEEE"/>
-                      </a:solidFill>
-                      <a:prstDash val="solid"/>
-                      <a:round/>
-                      <a:headEnd type="none" w="med" len="med"/>
-                      <a:tailEnd type="none" w="med" len="med"/>
-                    </a:lnT>
-                    <a:lnB w="2540" cap="flat" cmpd="sng" algn="ctr">
-                      <a:solidFill>
-                        <a:srgbClr val="EEEEEE"/>
-                      </a:solidFill>
-                      <a:prstDash val="solid"/>
-                      <a:round/>
-                      <a:headEnd type="none" w="med" len="med"/>
-                      <a:tailEnd type="none" w="med" len="med"/>
-                    </a:lnB>
-                  </a:tcPr>
-                </a:tc>
-                <a:tc>
-                  <a:txBody>
-                    <a:bodyPr/>
-                    <a:lstStyle/>
-                    <a:p>
-                      <a:pPr algn="ctr" indent="0" marL="0">
-                        <a:buNone/>
-                      </a:pPr>
-                      <a:r>
-                        <a:rPr lang="en-US" sz="500" dirty="0">
-                          <a:solidFill>
-                            <a:srgbClr val="777777"/>
-                          </a:solidFill>
-                          <a:latin typeface="Calibri" pitchFamily="34" charset="0"/>
-                          <a:ea typeface="Calibri" pitchFamily="34" charset="-122"/>
-                          <a:cs typeface="Calibri" pitchFamily="34" charset="-120"/>
-                        </a:rPr>
-                        <a:t>0.40%</a:t>
-                      </a:r>
-                      <a:endParaRPr lang="en-US" sz="500" dirty="0">
-                        <a:latin typeface="Calibri" charset="0"/>
-                        <a:ea typeface="Calibri" charset="0"/>
-                        <a:cs typeface="Calibri" charset="0"/>
-                      </a:endParaRPr>
-                    </a:p>
-                  </a:txBody>
-                  <a:tcPr marL="91440" marR="91440" marT="45720" marB="45720">
-                    <a:lnL w="2540" cap="flat" cmpd="sng" algn="ctr">
-                      <a:solidFill>
-                        <a:srgbClr val="EEEEEE"/>
-                      </a:solidFill>
-                      <a:prstDash val="solid"/>
-                      <a:round/>
-                      <a:headEnd type="none" w="med" len="med"/>
-                      <a:tailEnd type="none" w="med" len="med"/>
-                    </a:lnL>
-                    <a:lnR w="2540" cap="flat" cmpd="sng" algn="ctr">
-                      <a:solidFill>
-                        <a:srgbClr val="EEEEEE"/>
-                      </a:solidFill>
-                      <a:prstDash val="solid"/>
-                      <a:round/>
-                      <a:headEnd type="none" w="med" len="med"/>
-                      <a:tailEnd type="none" w="med" len="med"/>
-                    </a:lnR>
-                    <a:lnT w="2540" cap="flat" cmpd="sng" algn="ctr">
-                      <a:solidFill>
-                        <a:srgbClr val="EEEEEE"/>
-                      </a:solidFill>
-                      <a:prstDash val="solid"/>
-                      <a:round/>
-                      <a:headEnd type="none" w="med" len="med"/>
-                      <a:tailEnd type="none" w="med" len="med"/>
-                    </a:lnT>
-                    <a:lnB w="2540" cap="flat" cmpd="sng" algn="ctr">
-                      <a:solidFill>
-                        <a:srgbClr val="EEEEEE"/>
-                      </a:solidFill>
-                      <a:prstDash val="solid"/>
-                      <a:round/>
-                      <a:headEnd type="none" w="med" len="med"/>
-                      <a:tailEnd type="none" w="med" len="med"/>
-                    </a:lnB>
-                  </a:tcPr>
-                </a:tc>
-                <a:tc>
-                  <a:txBody>
-                    <a:bodyPr/>
-                    <a:lstStyle/>
-                    <a:p>
-                      <a:pPr algn="ctr" indent="0" marL="0">
-                        <a:buNone/>
-                      </a:pPr>
-                      <a:r>
-                        <a:rPr lang="en-US" sz="500" dirty="0">
-                          <a:solidFill>
-                            <a:srgbClr val="777777"/>
-                          </a:solidFill>
-                          <a:latin typeface="Calibri" pitchFamily="34" charset="0"/>
-                          <a:ea typeface="Calibri" pitchFamily="34" charset="-122"/>
-                          <a:cs typeface="Calibri" pitchFamily="34" charset="-120"/>
-                        </a:rPr>
-                        <a:t>0.39%</a:t>
-                      </a:r>
-                      <a:endParaRPr lang="en-US" sz="500" dirty="0">
-                        <a:latin typeface="Calibri" charset="0"/>
-                        <a:ea typeface="Calibri" charset="0"/>
-                        <a:cs typeface="Calibri" charset="0"/>
-                      </a:endParaRPr>
-                    </a:p>
-                  </a:txBody>
-                  <a:tcPr marL="91440" marR="91440" marT="45720" marB="45720">
-                    <a:lnL w="2540" cap="flat" cmpd="sng" algn="ctr">
-                      <a:solidFill>
-                        <a:srgbClr val="EEEEEE"/>
-                      </a:solidFill>
-                      <a:prstDash val="solid"/>
-                      <a:round/>
-                      <a:headEnd type="none" w="med" len="med"/>
-                      <a:tailEnd type="none" w="med" len="med"/>
-                    </a:lnL>
-                    <a:lnR w="2540" cap="flat" cmpd="sng" algn="ctr">
-                      <a:solidFill>
-                        <a:srgbClr val="EEEEEE"/>
-                      </a:solidFill>
-                      <a:prstDash val="solid"/>
-                      <a:round/>
-                      <a:headEnd type="none" w="med" len="med"/>
-                      <a:tailEnd type="none" w="med" len="med"/>
-                    </a:lnR>
-                    <a:lnT w="2540" cap="flat" cmpd="sng" algn="ctr">
-                      <a:solidFill>
-                        <a:srgbClr val="EEEEEE"/>
-                      </a:solidFill>
-                      <a:prstDash val="solid"/>
-                      <a:round/>
-                      <a:headEnd type="none" w="med" len="med"/>
-                      <a:tailEnd type="none" w="med" len="med"/>
-                    </a:lnT>
-                    <a:lnB w="2540" cap="flat" cmpd="sng" algn="ctr">
-                      <a:solidFill>
-                        <a:srgbClr val="EEEEEE"/>
-                      </a:solidFill>
-                      <a:prstDash val="solid"/>
-                      <a:round/>
-                      <a:headEnd type="none" w="med" len="med"/>
-                      <a:tailEnd type="none" w="med" len="med"/>
-                    </a:lnB>
-                  </a:tcPr>
-                </a:tc>
-                <a:tc>
-                  <a:txBody>
-                    <a:bodyPr/>
-                    <a:lstStyle/>
-                    <a:p>
-                      <a:pPr algn="ctr" indent="0" marL="0">
-                        <a:buNone/>
-                      </a:pPr>
-                      <a:r>
                         <a:rPr lang="en-US" sz="500" b="1" dirty="0">
                           <a:solidFill>
                             <a:srgbClr val="777777"/>
@@ -6937,7 +7009,7 @@
                           <a:ea typeface="Calibri" pitchFamily="34" charset="-122"/>
                           <a:cs typeface="Calibri" pitchFamily="34" charset="-120"/>
                         </a:rPr>
-                        <a:t>4.99%</a:t>
+                        <a:t>4.61%</a:t>
                       </a:r>
                       <a:endParaRPr lang="en-US" sz="500" dirty="0">
                         <a:latin typeface="Calibri" charset="0"/>
@@ -7123,7 +7195,7 @@
                           <a:ea typeface="Calibri" pitchFamily="34" charset="-122"/>
                           <a:cs typeface="Calibri" pitchFamily="34" charset="-120"/>
                         </a:rPr>
-                        <a:t>0.00%</a:t>
+                        <a:t>0.30%</a:t>
                       </a:r>
                       <a:endParaRPr lang="en-US" sz="500" dirty="0">
                         <a:latin typeface="Calibri" charset="0"/>
@@ -7578,7 +7650,7 @@
                           <a:ea typeface="Calibri" pitchFamily="34" charset="-122"/>
                           <a:cs typeface="Calibri" pitchFamily="34" charset="-120"/>
                         </a:rPr>
-                        <a:t>0.30%</a:t>
+                        <a:t>0.29%</a:t>
                       </a:r>
                       <a:endParaRPr lang="en-US" sz="500" dirty="0">
                         <a:latin typeface="Calibri" charset="0"/>
@@ -7838,7 +7910,7 @@
                           <a:ea typeface="Calibri" pitchFamily="34" charset="-122"/>
                           <a:cs typeface="Calibri" pitchFamily="34" charset="-120"/>
                         </a:rPr>
-                        <a:t>0.56%</a:t>
+                        <a:t>0.28%</a:t>
                       </a:r>
                       <a:endParaRPr lang="en-US" sz="500" dirty="0">
                         <a:latin typeface="Calibri" charset="0"/>
@@ -7903,7 +7975,7 @@
                           <a:ea typeface="Calibri" pitchFamily="34" charset="-122"/>
                           <a:cs typeface="Calibri" pitchFamily="34" charset="-120"/>
                         </a:rPr>
-                        <a:t>3.54%</a:t>
+                        <a:t>3.26%</a:t>
                       </a:r>
                       <a:endParaRPr lang="en-US" sz="500" dirty="0">
                         <a:latin typeface="Calibri" charset="0"/>
@@ -8016,7 +8088,7 @@
                         <a:buNone/>
                       </a:pPr>
                       <a:r>
-                        <a:rPr lang="en-US" sz="500" dirty="0">
+                        <a:rPr lang="en-US" sz="400" dirty="0">
                           <a:solidFill>
                             <a:srgbClr val="000000"/>
                           </a:solidFill>
@@ -8026,7 +8098,7 @@
                         </a:rPr>
                         <a:t>FIP LIQUIDEZ ACTIVA</a:t>
                       </a:r>
-                      <a:endParaRPr lang="en-US" sz="500" dirty="0">
+                      <a:endParaRPr lang="en-US" sz="400" dirty="0">
                         <a:latin typeface="Calibri" charset="0"/>
                         <a:ea typeface="Calibri" charset="0"/>
                         <a:cs typeface="Calibri" charset="0"/>
@@ -8080,6 +8152,17 @@
                       <a:pPr algn="ctr" indent="0" marL="0">
                         <a:buNone/>
                       </a:pPr>
+                      <a:r>
+                        <a:rPr lang="en-US" sz="500" dirty="0">
+                          <a:solidFill>
+                            <a:srgbClr val="000000"/>
+                          </a:solidFill>
+                          <a:latin typeface="Calibri" pitchFamily="34" charset="0"/>
+                          <a:ea typeface="Calibri" pitchFamily="34" charset="-122"/>
+                          <a:cs typeface="Calibri" pitchFamily="34" charset="-120"/>
+                        </a:rPr>
+                        <a:t>0.00%</a:t>
+                      </a:r>
                       <a:endParaRPr lang="en-US" sz="500" dirty="0">
                         <a:latin typeface="Calibri" charset="0"/>
                         <a:ea typeface="Calibri" charset="0"/>
@@ -8134,6 +8217,17 @@
                       <a:pPr algn="ctr" indent="0" marL="0">
                         <a:buNone/>
                       </a:pPr>
+                      <a:r>
+                        <a:rPr lang="en-US" sz="500" dirty="0">
+                          <a:solidFill>
+                            <a:srgbClr val="000000"/>
+                          </a:solidFill>
+                          <a:latin typeface="Calibri" pitchFamily="34" charset="0"/>
+                          <a:ea typeface="Calibri" pitchFamily="34" charset="-122"/>
+                          <a:cs typeface="Calibri" pitchFamily="34" charset="-120"/>
+                        </a:rPr>
+                        <a:t>0.00%</a:t>
+                      </a:r>
                       <a:endParaRPr lang="en-US" sz="500" dirty="0">
                         <a:latin typeface="Calibri" charset="0"/>
                         <a:ea typeface="Calibri" charset="0"/>
@@ -8188,6 +8282,17 @@
                       <a:pPr algn="ctr" indent="0" marL="0">
                         <a:buNone/>
                       </a:pPr>
+                      <a:r>
+                        <a:rPr lang="en-US" sz="500" dirty="0">
+                          <a:solidFill>
+                            <a:srgbClr val="000000"/>
+                          </a:solidFill>
+                          <a:latin typeface="Calibri" pitchFamily="34" charset="0"/>
+                          <a:ea typeface="Calibri" pitchFamily="34" charset="-122"/>
+                          <a:cs typeface="Calibri" pitchFamily="34" charset="-120"/>
+                        </a:rPr>
+                        <a:t>0.00%</a:t>
+                      </a:r>
                       <a:endParaRPr lang="en-US" sz="500" dirty="0">
                         <a:latin typeface="Calibri" charset="0"/>
                         <a:ea typeface="Calibri" charset="0"/>
@@ -9033,7 +9138,7 @@
                           <a:ea typeface="Calibri" pitchFamily="34" charset="-122"/>
                           <a:cs typeface="Calibri" pitchFamily="34" charset="-120"/>
                         </a:rPr>
-                        <a:t>0.37%</a:t>
+                        <a:t>0.39%</a:t>
                       </a:r>
                       <a:endParaRPr lang="en-US" sz="500" dirty="0">
                         <a:latin typeface="Calibri" charset="0"/>
@@ -9098,7 +9203,7 @@
                           <a:ea typeface="Calibri" pitchFamily="34" charset="-122"/>
                           <a:cs typeface="Calibri" pitchFamily="34" charset="-120"/>
                         </a:rPr>
-                        <a:t>0.37%</a:t>
+                        <a:t>0.36%</a:t>
                       </a:r>
                       <a:endParaRPr lang="en-US" sz="500" dirty="0">
                         <a:latin typeface="Calibri" charset="0"/>
@@ -9163,7 +9268,7 @@
                           <a:ea typeface="Calibri" pitchFamily="34" charset="-122"/>
                           <a:cs typeface="Calibri" pitchFamily="34" charset="-120"/>
                         </a:rPr>
-                        <a:t>0.37%</a:t>
+                        <a:t>0.39%</a:t>
                       </a:r>
                       <a:endParaRPr lang="en-US" sz="500" dirty="0">
                         <a:latin typeface="Calibri" charset="0"/>
@@ -9228,7 +9333,7 @@
                           <a:ea typeface="Calibri" pitchFamily="34" charset="-122"/>
                           <a:cs typeface="Calibri" pitchFamily="34" charset="-120"/>
                         </a:rPr>
-                        <a:t>0.37%</a:t>
+                        <a:t>0.38%</a:t>
                       </a:r>
                       <a:endParaRPr lang="en-US" sz="500" dirty="0">
                         <a:latin typeface="Calibri" charset="0"/>
@@ -9911,7 +10016,7 @@
                           <a:ea typeface="Calibri" pitchFamily="34" charset="-122"/>
                           <a:cs typeface="Calibri" pitchFamily="34" charset="-120"/>
                         </a:rPr>
-                        <a:t>0.00%</a:t>
+                        <a:t>0.27%</a:t>
                       </a:r>
                       <a:endParaRPr lang="en-US" sz="500" dirty="0">
                         <a:latin typeface="Calibri" charset="0"/>
@@ -10716,7 +10821,7 @@
                         <a:buNone/>
                       </a:pPr>
                       <a:r>
-                        <a:rPr lang="en-US" sz="500" dirty="0">
+                        <a:rPr lang="en-US" sz="400" dirty="0">
                           <a:solidFill>
                             <a:srgbClr val="000000"/>
                           </a:solidFill>
@@ -10726,7 +10831,7 @@
                         </a:rPr>
                         <a:t>FIP LIQUIDEZ ACTIVA</a:t>
                       </a:r>
-                      <a:endParaRPr lang="en-US" sz="500" dirty="0">
+                      <a:endParaRPr lang="en-US" sz="400" dirty="0">
                         <a:latin typeface="Calibri" charset="0"/>
                         <a:ea typeface="Calibri" charset="0"/>
                         <a:cs typeface="Calibri" charset="0"/>

</xml_diff>